<commit_message>
Site updated: 2026-10-12 22:36:52
</commit_message>
<xml_diff>
--- a/files/creating-a-meaningful-life.pptx
+++ b/files/creating-a-meaningful-life.pptx
@@ -512,7 +512,7 @@
           <a:lstStyle/>
           <a:p>
             <a:r>
-              <a:t>开场约30秒：你有没有觉得自己"不够好"过？如果有，今天我想讲的，可能和你有关。</a:t>
+              <a:t/>
             </a:r>
           </a:p>
         </p:txBody>
@@ -582,7 +582,7 @@
           <a:lstStyle/>
           <a:p>
             <a:r>
-              <a:t>意义是动态过程；标准是"成长+对他人有用"，落回社会价值。</a:t>
+              <a:t/>
             </a:r>
           </a:p>
         </p:txBody>
@@ -652,7 +652,7 @@
           <a:lstStyle/>
           <a:p>
             <a:r>
-              <a:t>谢谢大家，我的分享到这里。</a:t>
+              <a:t/>
             </a:r>
           </a:p>
         </p:txBody>
@@ -722,7 +722,7 @@
           <a:lstStyle/>
           <a:p>
             <a:r>
-              <a:t>现场抛问题，互动10秒。</a:t>
+              <a:t/>
             </a:r>
           </a:p>
         </p:txBody>
@@ -792,7 +792,7 @@
           <a:lstStyle/>
           <a:p>
             <a:r>
-              <a:t>点题：第一章节第三节，用自身经历对应三个知识点。</a:t>
+              <a:t/>
             </a:r>
           </a:p>
         </p:txBody>
@@ -862,7 +862,7 @@
           <a:lstStyle/>
           <a:p>
             <a:r>
-              <a:t>主体一约90秒：两次被否定，重点写当下的自我怀疑。</a:t>
+              <a:t/>
             </a:r>
           </a:p>
         </p:txBody>
@@ -932,7 +932,7 @@
           <a:lstStyle/>
           <a:p>
             <a:r>
-              <a:t>主体二约40秒：把"我"放大成"我们"。</a:t>
+              <a:t/>
             </a:r>
           </a:p>
         </p:txBody>
@@ -1002,7 +1002,7 @@
           <a:lstStyle/>
           <a:p>
             <a:r>
-              <a:t>主体三约70秒：五观+三个关键词，强调"一定条件"。</a:t>
+              <a:t/>
             </a:r>
           </a:p>
         </p:txBody>
@@ -1072,7 +1072,7 @@
           <a:lstStyle/>
           <a:p>
             <a:r>
-              <a:t>用正确价值观把尺子拿回自己手里。</a:t>
+              <a:t/>
             </a:r>
           </a:p>
         </p:txBody>
@@ -1142,7 +1142,7 @@
           <a:lstStyle/>
           <a:p>
             <a:r>
-              <a:t>存在主义借力提问题，马克思给答案；落点社会价值。</a:t>
+              <a:t/>
             </a:r>
           </a:p>
         </p:txBody>
@@ -1212,7 +1212,7 @@
           <a:lstStyle/>
           <a:p>
             <a:r>
-              <a:t>收尾约60秒：动画、哲学、编程三条线，都由"想找到自己的价值"推动。</a:t>
+              <a:t/>
             </a:r>
           </a:p>
         </p:txBody>

</xml_diff>

<commit_message>
Site updated: 2026-10-13 19:58:29
</commit_message>
<xml_diff>
--- a/files/creating-a-meaningful-life.pptx
+++ b/files/creating-a-meaningful-life.pptx
@@ -3159,7 +3159,7 @@
             </a:avLst>
           </a:prstGeom>
           <a:solidFill>
-            <a:srgbClr val="2F4858"/>
+            <a:srgbClr val="EEF2F5"/>
           </a:solidFill>
           <a:ln>
             <a:noFill/>
@@ -3190,128 +3190,20 @@
       </p:sp>
       <p:sp>
         <p:nvSpPr>
-          <p:cNvPr id="4" name="TextBox 3"/>
-          <p:cNvSpPr txBox="1"/>
-          <p:nvPr/>
-        </p:nvSpPr>
-        <p:spPr>
-          <a:xfrm>
-            <a:off x="7818120" y="1783080"/>
-            <a:ext cx="3200400" cy="3291840"/>
-          </a:xfrm>
-          <a:prstGeom prst="rect">
-            <a:avLst/>
-          </a:prstGeom>
-          <a:noFill/>
-        </p:spPr>
-        <p:txBody>
-          <a:bodyPr wrap="square" anchor="t">
-            <a:spAutoFit/>
-          </a:bodyPr>
-          <a:lstStyle/>
-          <a:p>
-            <a:pPr algn="l">
-              <a:lnSpc>
-                <a:spcPct val="150000"/>
-              </a:lnSpc>
-            </a:pPr>
-            <a:r>
-              <a:rPr sz="1550" b="0">
-                <a:solidFill>
-                  <a:srgbClr val="FFFFFF"/>
-                </a:solidFill>
-                <a:latin typeface="Noto Serif SC"/>
-                <a:ea typeface="Noto Serif SC"/>
-              </a:rPr>
-              <a:t>人生的意义，</a:t>
-            </a:r>
-          </a:p>
-          <a:p>
-            <a:pPr algn="l">
-              <a:lnSpc>
-                <a:spcPct val="150000"/>
-              </a:lnSpc>
-            </a:pPr>
-            <a:r>
-              <a:rPr sz="1550" b="0">
-                <a:solidFill>
-                  <a:srgbClr val="FFFFFF"/>
-                </a:solidFill>
-                <a:latin typeface="Noto Serif SC"/>
-                <a:ea typeface="Noto Serif SC"/>
-              </a:rPr>
-              <a:t>不是一次算清的答案，</a:t>
-            </a:r>
-          </a:p>
-          <a:p>
-            <a:pPr algn="l">
-              <a:lnSpc>
-                <a:spcPct val="150000"/>
-              </a:lnSpc>
-            </a:pPr>
-            <a:r>
-              <a:rPr sz="1550" b="0">
-                <a:solidFill>
-                  <a:srgbClr val="FFFFFF"/>
-                </a:solidFill>
-                <a:latin typeface="Noto Serif SC"/>
-                <a:ea typeface="Noto Serif SC"/>
-              </a:rPr>
-              <a:t>而是在矛盾中，</a:t>
-            </a:r>
-          </a:p>
-          <a:p>
-            <a:pPr algn="l">
-              <a:lnSpc>
-                <a:spcPct val="150000"/>
-              </a:lnSpc>
-            </a:pPr>
-            <a:r>
-              <a:rPr sz="1550" b="0">
-                <a:solidFill>
-                  <a:srgbClr val="FFFFFF"/>
-                </a:solidFill>
-                <a:latin typeface="Noto Serif SC"/>
-                <a:ea typeface="Noto Serif SC"/>
-              </a:rPr>
-              <a:t>不断被重新书写的</a:t>
-            </a:r>
-          </a:p>
-          <a:p>
-            <a:pPr algn="l">
-              <a:lnSpc>
-                <a:spcPct val="150000"/>
-              </a:lnSpc>
-            </a:pPr>
-            <a:r>
-              <a:rPr sz="1550" b="0">
-                <a:solidFill>
-                  <a:srgbClr val="FFFFFF"/>
-                </a:solidFill>
-                <a:latin typeface="Noto Serif SC"/>
-                <a:ea typeface="Noto Serif SC"/>
-              </a:rPr>
-              <a:t>动态过程。</a:t>
-            </a:r>
-          </a:p>
-        </p:txBody>
-      </p:sp>
-      <p:sp>
-        <p:nvSpPr>
-          <p:cNvPr id="5" name="Rectangle 4"/>
+          <p:cNvPr id="4" name="Rectangle 3"/>
           <p:cNvSpPr/>
           <p:nvPr/>
         </p:nvSpPr>
         <p:spPr>
           <a:xfrm>
-            <a:off x="7818120" y="4846320"/>
-            <a:ext cx="1371600" cy="18288"/>
-          </a:xfrm>
-          <a:prstGeom prst="rect">
-            <a:avLst/>
-          </a:prstGeom>
-          <a:solidFill>
-            <a:srgbClr val="8FA6B4"/>
+            <a:off x="7452360" y="1188720"/>
+            <a:ext cx="64008" cy="4526280"/>
+          </a:xfrm>
+          <a:prstGeom prst="rect">
+            <a:avLst/>
+          </a:prstGeom>
+          <a:solidFill>
+            <a:srgbClr val="52798A"/>
           </a:solidFill>
           <a:ln>
             <a:noFill/>
@@ -3342,122 +3234,14 @@
       </p:sp>
       <p:sp>
         <p:nvSpPr>
-          <p:cNvPr id="6" name="TextBox 5"/>
-          <p:cNvSpPr txBox="1"/>
-          <p:nvPr/>
-        </p:nvSpPr>
-        <p:spPr>
-          <a:xfrm>
-            <a:off x="7818120" y="4983480"/>
-            <a:ext cx="3108960" cy="365760"/>
-          </a:xfrm>
-          <a:prstGeom prst="rect">
-            <a:avLst/>
-          </a:prstGeom>
-          <a:noFill/>
-        </p:spPr>
-        <p:txBody>
-          <a:bodyPr wrap="square" anchor="t">
-            <a:spAutoFit/>
-          </a:bodyPr>
-          <a:lstStyle/>
-          <a:p>
-            <a:pPr algn="l"/>
-            <a:r>
-              <a:rPr sz="1100" b="0">
-                <a:solidFill>
-                  <a:srgbClr val="8FA6B4"/>
-                </a:solidFill>
-                <a:latin typeface="微软雅黑"/>
-                <a:ea typeface="微软雅黑"/>
-              </a:rPr>
-              <a:t>第一章 · 第三节</a:t>
-            </a:r>
-          </a:p>
-        </p:txBody>
-      </p:sp>
-      <p:sp>
-        <p:nvSpPr>
-          <p:cNvPr id="7" name="TextBox 6"/>
-          <p:cNvSpPr txBox="1"/>
-          <p:nvPr/>
-        </p:nvSpPr>
-        <p:spPr>
-          <a:xfrm>
-            <a:off x="960120" y="960120"/>
-            <a:ext cx="6035040" cy="320040"/>
-          </a:xfrm>
-          <a:prstGeom prst="rect">
-            <a:avLst/>
-          </a:prstGeom>
-          <a:noFill/>
-        </p:spPr>
-        <p:txBody>
-          <a:bodyPr wrap="square" anchor="t">
-            <a:spAutoFit/>
-          </a:bodyPr>
-          <a:lstStyle/>
-          <a:p>
-            <a:pPr algn="l"/>
-            <a:r>
-              <a:rPr sz="1250" b="0">
-                <a:solidFill>
-                  <a:srgbClr val="5F6B76"/>
-                </a:solidFill>
-                <a:latin typeface="微软雅黑"/>
-                <a:ea typeface="微软雅黑"/>
-              </a:rPr>
-              <a:t>思想道德与法治 · 课前分享</a:t>
-            </a:r>
-          </a:p>
-        </p:txBody>
-      </p:sp>
-      <p:sp>
-        <p:nvSpPr>
-          <p:cNvPr id="8" name="TextBox 7"/>
-          <p:cNvSpPr txBox="1"/>
-          <p:nvPr/>
-        </p:nvSpPr>
-        <p:spPr>
-          <a:xfrm>
-            <a:off x="960120" y="2240280"/>
-            <a:ext cx="6217920" cy="914400"/>
-          </a:xfrm>
-          <a:prstGeom prst="rect">
-            <a:avLst/>
-          </a:prstGeom>
-          <a:noFill/>
-        </p:spPr>
-        <p:txBody>
-          <a:bodyPr wrap="square" anchor="t">
-            <a:spAutoFit/>
-          </a:bodyPr>
-          <a:lstStyle/>
-          <a:p>
-            <a:pPr algn="l"/>
-            <a:r>
-              <a:rPr sz="4000" b="0">
-                <a:solidFill>
-                  <a:srgbClr val="1B1B1B"/>
-                </a:solidFill>
-                <a:latin typeface="微软雅黑 Light"/>
-                <a:ea typeface="微软雅黑 Light"/>
-              </a:rPr>
-              <a:t>创造有意义的人生</a:t>
-            </a:r>
-          </a:p>
-        </p:txBody>
-      </p:sp>
-      <p:sp>
-        <p:nvSpPr>
-          <p:cNvPr id="9" name="Rectangle 8"/>
+          <p:cNvPr id="5" name="Rectangle 4"/>
           <p:cNvSpPr/>
           <p:nvPr/>
         </p:nvSpPr>
         <p:spPr>
           <a:xfrm>
-            <a:off x="960120" y="3310128"/>
-            <a:ext cx="1737360" cy="45720"/>
+            <a:off x="7818120" y="1536192"/>
+            <a:ext cx="118872" cy="118872"/>
           </a:xfrm>
           <a:prstGeom prst="rect">
             <a:avLst/>
@@ -3494,7 +3278,521 @@
       </p:sp>
       <p:sp>
         <p:nvSpPr>
-          <p:cNvPr id="10" name="TextBox 9"/>
+          <p:cNvPr id="6" name="TextBox 5"/>
+          <p:cNvSpPr txBox="1"/>
+          <p:nvPr/>
+        </p:nvSpPr>
+        <p:spPr>
+          <a:xfrm>
+            <a:off x="8037575" y="1481328"/>
+            <a:ext cx="3017520" cy="320040"/>
+          </a:xfrm>
+          <a:prstGeom prst="rect">
+            <a:avLst/>
+          </a:prstGeom>
+          <a:noFill/>
+        </p:spPr>
+        <p:txBody>
+          <a:bodyPr wrap="square" anchor="t">
+            <a:spAutoFit/>
+          </a:bodyPr>
+          <a:lstStyle/>
+          <a:p>
+            <a:pPr algn="l"/>
+            <a:r>
+              <a:rPr sz="1200" b="0">
+                <a:solidFill>
+                  <a:srgbClr val="2F4858"/>
+                </a:solidFill>
+                <a:latin typeface="微软雅黑"/>
+                <a:ea typeface="微软雅黑"/>
+              </a:rPr>
+              <a:t>本次分享</a:t>
+            </a:r>
+          </a:p>
+        </p:txBody>
+      </p:sp>
+      <p:sp>
+        <p:nvSpPr>
+          <p:cNvPr id="7" name="Rectangle 6"/>
+          <p:cNvSpPr/>
+          <p:nvPr/>
+        </p:nvSpPr>
+        <p:spPr>
+          <a:xfrm>
+            <a:off x="7818120" y="1993392"/>
+            <a:ext cx="3108960" cy="12801"/>
+          </a:xfrm>
+          <a:prstGeom prst="rect">
+            <a:avLst/>
+          </a:prstGeom>
+          <a:solidFill>
+            <a:srgbClr val="8FA6B4"/>
+          </a:solidFill>
+          <a:ln>
+            <a:noFill/>
+          </a:ln>
+          <a:effectLst/>
+        </p:spPr>
+        <p:style>
+          <a:lnRef idx="1">
+            <a:schemeClr val="accent1"/>
+          </a:lnRef>
+          <a:fillRef idx="3">
+            <a:schemeClr val="accent1"/>
+          </a:fillRef>
+          <a:effectRef idx="2">
+            <a:schemeClr val="accent1"/>
+          </a:effectRef>
+          <a:fontRef idx="minor">
+            <a:schemeClr val="lt1"/>
+          </a:fontRef>
+        </p:style>
+        <p:txBody>
+          <a:bodyPr rtlCol="0" anchor="ctr"/>
+          <a:lstStyle/>
+          <a:p>
+            <a:pPr algn="ctr"/>
+          </a:p>
+        </p:txBody>
+      </p:sp>
+      <p:sp>
+        <p:nvSpPr>
+          <p:cNvPr id="8" name="Rounded Rectangle 7"/>
+          <p:cNvSpPr/>
+          <p:nvPr/>
+        </p:nvSpPr>
+        <p:spPr>
+          <a:xfrm>
+            <a:off x="7818120" y="2286000"/>
+            <a:ext cx="3108960" cy="658368"/>
+          </a:xfrm>
+          <a:prstGeom prst="roundRect">
+            <a:avLst>
+              <a:gd name="adj" fmla="val 14000"/>
+            </a:avLst>
+          </a:prstGeom>
+          <a:solidFill>
+            <a:srgbClr val="E2EAEF"/>
+          </a:solidFill>
+          <a:ln>
+            <a:noFill/>
+          </a:ln>
+          <a:effectLst/>
+        </p:spPr>
+        <p:style>
+          <a:lnRef idx="1">
+            <a:schemeClr val="accent1"/>
+          </a:lnRef>
+          <a:fillRef idx="3">
+            <a:schemeClr val="accent1"/>
+          </a:fillRef>
+          <a:effectRef idx="2">
+            <a:schemeClr val="accent1"/>
+          </a:effectRef>
+          <a:fontRef idx="minor">
+            <a:schemeClr val="lt1"/>
+          </a:fontRef>
+        </p:style>
+        <p:txBody>
+          <a:bodyPr rtlCol="0" anchor="ctr"/>
+          <a:lstStyle/>
+          <a:p>
+            <a:pPr algn="ctr"/>
+          </a:p>
+        </p:txBody>
+      </p:sp>
+      <p:sp>
+        <p:nvSpPr>
+          <p:cNvPr id="9" name="TextBox 8"/>
+          <p:cNvSpPr txBox="1"/>
+          <p:nvPr/>
+        </p:nvSpPr>
+        <p:spPr>
+          <a:xfrm>
+            <a:off x="7818120" y="2286000"/>
+            <a:ext cx="3108960" cy="658368"/>
+          </a:xfrm>
+          <a:prstGeom prst="rect">
+            <a:avLst/>
+          </a:prstGeom>
+          <a:noFill/>
+        </p:spPr>
+        <p:txBody>
+          <a:bodyPr wrap="square" anchor="ctr">
+            <a:spAutoFit/>
+          </a:bodyPr>
+          <a:lstStyle/>
+          <a:p>
+            <a:pPr algn="ctr"/>
+            <a:r>
+              <a:rPr sz="1700" b="0">
+                <a:solidFill>
+                  <a:srgbClr val="2F4858"/>
+                </a:solidFill>
+                <a:latin typeface="微软雅黑"/>
+                <a:ea typeface="微软雅黑"/>
+              </a:rPr>
+              <a:t>动画</a:t>
+            </a:r>
+          </a:p>
+        </p:txBody>
+      </p:sp>
+      <p:sp>
+        <p:nvSpPr>
+          <p:cNvPr id="10" name="Rounded Rectangle 9"/>
+          <p:cNvSpPr/>
+          <p:nvPr/>
+        </p:nvSpPr>
+        <p:spPr>
+          <a:xfrm>
+            <a:off x="7818120" y="3090672"/>
+            <a:ext cx="3108960" cy="658368"/>
+          </a:xfrm>
+          <a:prstGeom prst="roundRect">
+            <a:avLst>
+              <a:gd name="adj" fmla="val 14000"/>
+            </a:avLst>
+          </a:prstGeom>
+          <a:solidFill>
+            <a:srgbClr val="E2EAEF"/>
+          </a:solidFill>
+          <a:ln>
+            <a:noFill/>
+          </a:ln>
+          <a:effectLst/>
+        </p:spPr>
+        <p:style>
+          <a:lnRef idx="1">
+            <a:schemeClr val="accent1"/>
+          </a:lnRef>
+          <a:fillRef idx="3">
+            <a:schemeClr val="accent1"/>
+          </a:fillRef>
+          <a:effectRef idx="2">
+            <a:schemeClr val="accent1"/>
+          </a:effectRef>
+          <a:fontRef idx="minor">
+            <a:schemeClr val="lt1"/>
+          </a:fontRef>
+        </p:style>
+        <p:txBody>
+          <a:bodyPr rtlCol="0" anchor="ctr"/>
+          <a:lstStyle/>
+          <a:p>
+            <a:pPr algn="ctr"/>
+          </a:p>
+        </p:txBody>
+      </p:sp>
+      <p:sp>
+        <p:nvSpPr>
+          <p:cNvPr id="11" name="TextBox 10"/>
+          <p:cNvSpPr txBox="1"/>
+          <p:nvPr/>
+        </p:nvSpPr>
+        <p:spPr>
+          <a:xfrm>
+            <a:off x="7818120" y="3090672"/>
+            <a:ext cx="3108960" cy="658368"/>
+          </a:xfrm>
+          <a:prstGeom prst="rect">
+            <a:avLst/>
+          </a:prstGeom>
+          <a:noFill/>
+        </p:spPr>
+        <p:txBody>
+          <a:bodyPr wrap="square" anchor="ctr">
+            <a:spAutoFit/>
+          </a:bodyPr>
+          <a:lstStyle/>
+          <a:p>
+            <a:pPr algn="ctr"/>
+            <a:r>
+              <a:rPr sz="1700" b="0">
+                <a:solidFill>
+                  <a:srgbClr val="2F4858"/>
+                </a:solidFill>
+                <a:latin typeface="微软雅黑"/>
+                <a:ea typeface="微软雅黑"/>
+              </a:rPr>
+              <a:t>哲学</a:t>
+            </a:r>
+          </a:p>
+        </p:txBody>
+      </p:sp>
+      <p:sp>
+        <p:nvSpPr>
+          <p:cNvPr id="12" name="Rounded Rectangle 11"/>
+          <p:cNvSpPr/>
+          <p:nvPr/>
+        </p:nvSpPr>
+        <p:spPr>
+          <a:xfrm>
+            <a:off x="7818120" y="3895344"/>
+            <a:ext cx="3108960" cy="658368"/>
+          </a:xfrm>
+          <a:prstGeom prst="roundRect">
+            <a:avLst>
+              <a:gd name="adj" fmla="val 14000"/>
+            </a:avLst>
+          </a:prstGeom>
+          <a:solidFill>
+            <a:srgbClr val="E2EAEF"/>
+          </a:solidFill>
+          <a:ln>
+            <a:noFill/>
+          </a:ln>
+          <a:effectLst/>
+        </p:spPr>
+        <p:style>
+          <a:lnRef idx="1">
+            <a:schemeClr val="accent1"/>
+          </a:lnRef>
+          <a:fillRef idx="3">
+            <a:schemeClr val="accent1"/>
+          </a:fillRef>
+          <a:effectRef idx="2">
+            <a:schemeClr val="accent1"/>
+          </a:effectRef>
+          <a:fontRef idx="minor">
+            <a:schemeClr val="lt1"/>
+          </a:fontRef>
+        </p:style>
+        <p:txBody>
+          <a:bodyPr rtlCol="0" anchor="ctr"/>
+          <a:lstStyle/>
+          <a:p>
+            <a:pPr algn="ctr"/>
+          </a:p>
+        </p:txBody>
+      </p:sp>
+      <p:sp>
+        <p:nvSpPr>
+          <p:cNvPr id="13" name="TextBox 12"/>
+          <p:cNvSpPr txBox="1"/>
+          <p:nvPr/>
+        </p:nvSpPr>
+        <p:spPr>
+          <a:xfrm>
+            <a:off x="7818120" y="3895344"/>
+            <a:ext cx="3108960" cy="658368"/>
+          </a:xfrm>
+          <a:prstGeom prst="rect">
+            <a:avLst/>
+          </a:prstGeom>
+          <a:noFill/>
+        </p:spPr>
+        <p:txBody>
+          <a:bodyPr wrap="square" anchor="ctr">
+            <a:spAutoFit/>
+          </a:bodyPr>
+          <a:lstStyle/>
+          <a:p>
+            <a:pPr algn="ctr"/>
+            <a:r>
+              <a:rPr sz="1700" b="0">
+                <a:solidFill>
+                  <a:srgbClr val="2F4858"/>
+                </a:solidFill>
+                <a:latin typeface="微软雅黑"/>
+                <a:ea typeface="微软雅黑"/>
+              </a:rPr>
+              <a:t>编程</a:t>
+            </a:r>
+          </a:p>
+        </p:txBody>
+      </p:sp>
+      <p:sp>
+        <p:nvSpPr>
+          <p:cNvPr id="14" name="TextBox 13"/>
+          <p:cNvSpPr txBox="1"/>
+          <p:nvPr/>
+        </p:nvSpPr>
+        <p:spPr>
+          <a:xfrm>
+            <a:off x="7818120" y="4828032"/>
+            <a:ext cx="3108960" cy="365760"/>
+          </a:xfrm>
+          <a:prstGeom prst="rect">
+            <a:avLst/>
+          </a:prstGeom>
+          <a:noFill/>
+        </p:spPr>
+        <p:txBody>
+          <a:bodyPr wrap="square" anchor="t">
+            <a:spAutoFit/>
+          </a:bodyPr>
+          <a:lstStyle/>
+          <a:p>
+            <a:pPr algn="l"/>
+            <a:r>
+              <a:rPr sz="1150" b="0">
+                <a:solidFill>
+                  <a:srgbClr val="5F6B76"/>
+                </a:solidFill>
+                <a:latin typeface="微软雅黑"/>
+                <a:ea typeface="微软雅黑"/>
+              </a:rPr>
+              <a:t>一次关于「意义」的自言自语</a:t>
+            </a:r>
+          </a:p>
+        </p:txBody>
+      </p:sp>
+      <p:sp>
+        <p:nvSpPr>
+          <p:cNvPr id="15" name="TextBox 14"/>
+          <p:cNvSpPr txBox="1"/>
+          <p:nvPr/>
+        </p:nvSpPr>
+        <p:spPr>
+          <a:xfrm>
+            <a:off x="7818120" y="5321808"/>
+            <a:ext cx="3108960" cy="320040"/>
+          </a:xfrm>
+          <a:prstGeom prst="rect">
+            <a:avLst/>
+          </a:prstGeom>
+          <a:noFill/>
+        </p:spPr>
+        <p:txBody>
+          <a:bodyPr wrap="square" anchor="t">
+            <a:spAutoFit/>
+          </a:bodyPr>
+          <a:lstStyle/>
+          <a:p>
+            <a:pPr algn="l"/>
+            <a:r>
+              <a:rPr sz="1050" b="0">
+                <a:solidFill>
+                  <a:srgbClr val="98A2AB"/>
+                </a:solidFill>
+                <a:latin typeface="微软雅黑"/>
+                <a:ea typeface="微软雅黑"/>
+              </a:rPr>
+              <a:t>第一章 · 第三节</a:t>
+            </a:r>
+          </a:p>
+        </p:txBody>
+      </p:sp>
+      <p:sp>
+        <p:nvSpPr>
+          <p:cNvPr id="16" name="TextBox 15"/>
+          <p:cNvSpPr txBox="1"/>
+          <p:nvPr/>
+        </p:nvSpPr>
+        <p:spPr>
+          <a:xfrm>
+            <a:off x="960120" y="960120"/>
+            <a:ext cx="6035040" cy="320040"/>
+          </a:xfrm>
+          <a:prstGeom prst="rect">
+            <a:avLst/>
+          </a:prstGeom>
+          <a:noFill/>
+        </p:spPr>
+        <p:txBody>
+          <a:bodyPr wrap="square" anchor="t">
+            <a:spAutoFit/>
+          </a:bodyPr>
+          <a:lstStyle/>
+          <a:p>
+            <a:pPr algn="l"/>
+            <a:r>
+              <a:rPr sz="1250" b="0">
+                <a:solidFill>
+                  <a:srgbClr val="5F6B76"/>
+                </a:solidFill>
+                <a:latin typeface="微软雅黑"/>
+                <a:ea typeface="微软雅黑"/>
+              </a:rPr>
+              <a:t>思想道德与法治 · 课前分享</a:t>
+            </a:r>
+          </a:p>
+        </p:txBody>
+      </p:sp>
+      <p:sp>
+        <p:nvSpPr>
+          <p:cNvPr id="17" name="TextBox 16"/>
+          <p:cNvSpPr txBox="1"/>
+          <p:nvPr/>
+        </p:nvSpPr>
+        <p:spPr>
+          <a:xfrm>
+            <a:off x="960120" y="2240280"/>
+            <a:ext cx="6217920" cy="914400"/>
+          </a:xfrm>
+          <a:prstGeom prst="rect">
+            <a:avLst/>
+          </a:prstGeom>
+          <a:noFill/>
+        </p:spPr>
+        <p:txBody>
+          <a:bodyPr wrap="square" anchor="t">
+            <a:spAutoFit/>
+          </a:bodyPr>
+          <a:lstStyle/>
+          <a:p>
+            <a:pPr algn="l"/>
+            <a:r>
+              <a:rPr sz="4000" b="0">
+                <a:solidFill>
+                  <a:srgbClr val="1B1B1B"/>
+                </a:solidFill>
+                <a:latin typeface="微软雅黑 Light"/>
+                <a:ea typeface="微软雅黑 Light"/>
+              </a:rPr>
+              <a:t>创造有意义的人生</a:t>
+            </a:r>
+          </a:p>
+        </p:txBody>
+      </p:sp>
+      <p:sp>
+        <p:nvSpPr>
+          <p:cNvPr id="18" name="Rectangle 17"/>
+          <p:cNvSpPr/>
+          <p:nvPr/>
+        </p:nvSpPr>
+        <p:spPr>
+          <a:xfrm>
+            <a:off x="960120" y="3310128"/>
+            <a:ext cx="1737360" cy="45720"/>
+          </a:xfrm>
+          <a:prstGeom prst="rect">
+            <a:avLst/>
+          </a:prstGeom>
+          <a:solidFill>
+            <a:srgbClr val="52798A"/>
+          </a:solidFill>
+          <a:ln>
+            <a:noFill/>
+          </a:ln>
+          <a:effectLst/>
+        </p:spPr>
+        <p:style>
+          <a:lnRef idx="1">
+            <a:schemeClr val="accent1"/>
+          </a:lnRef>
+          <a:fillRef idx="3">
+            <a:schemeClr val="accent1"/>
+          </a:fillRef>
+          <a:effectRef idx="2">
+            <a:schemeClr val="accent1"/>
+          </a:effectRef>
+          <a:fontRef idx="minor">
+            <a:schemeClr val="lt1"/>
+          </a:fontRef>
+        </p:style>
+        <p:txBody>
+          <a:bodyPr rtlCol="0" anchor="ctr"/>
+          <a:lstStyle/>
+          <a:p>
+            <a:pPr algn="ctr"/>
+          </a:p>
+        </p:txBody>
+      </p:sp>
+      <p:sp>
+        <p:nvSpPr>
+          <p:cNvPr id="19" name="TextBox 18"/>
           <p:cNvSpPr txBox="1"/>
           <p:nvPr/>
         </p:nvSpPr>
@@ -3530,7 +3828,7 @@
       </p:sp>
       <p:sp>
         <p:nvSpPr>
-          <p:cNvPr id="11" name="TextBox 10"/>
+          <p:cNvPr id="20" name="TextBox 19"/>
           <p:cNvSpPr txBox="1"/>
           <p:nvPr/>
         </p:nvSpPr>
@@ -3583,7 +3881,7 @@
       </p:sp>
       <p:sp>
         <p:nvSpPr>
-          <p:cNvPr id="12" name="TextBox 11"/>
+          <p:cNvPr id="21" name="TextBox 20"/>
           <p:cNvSpPr txBox="1"/>
           <p:nvPr/>
         </p:nvSpPr>
@@ -3619,7 +3917,7 @@
       </p:sp>
       <p:sp>
         <p:nvSpPr>
-          <p:cNvPr id="13" name="TextBox 12"/>
+          <p:cNvPr id="22" name="TextBox 21"/>
           <p:cNvSpPr txBox="1"/>
           <p:nvPr/>
         </p:nvSpPr>
@@ -5222,7 +5520,7 @@
                 <a:latin typeface="微软雅黑"/>
                 <a:ea typeface="微软雅黑"/>
               </a:rPr>
-              <a:t>本节框架</a:t>
+              <a:t>这次聊什么</a:t>
             </a:r>
           </a:p>
         </p:txBody>
@@ -5258,7 +5556,7 @@
                 <a:latin typeface="微软雅黑 Light"/>
                 <a:ea typeface="微软雅黑 Light"/>
               </a:rPr>
-              <a:t>本节课的三个知识点</a:t>
+              <a:t>书里提到的三点，我想聊聊</a:t>
             </a:r>
           </a:p>
         </p:txBody>
@@ -5324,7 +5622,7 @@
             </a:avLst>
           </a:prstGeom>
           <a:solidFill>
-            <a:srgbClr val="2F4858"/>
+            <a:srgbClr val="E2EAEF"/>
           </a:solidFill>
           <a:ln>
             <a:noFill/>
@@ -5379,7 +5677,7 @@
             <a:r>
               <a:rPr sz="1500" b="0">
                 <a:solidFill>
-                  <a:srgbClr val="FFFFFF"/>
+                  <a:srgbClr val="2F4858"/>
                 </a:solidFill>
                 <a:latin typeface="微软雅黑"/>
                 <a:ea typeface="微软雅黑"/>
@@ -5486,7 +5784,7 @@
             </a:avLst>
           </a:prstGeom>
           <a:solidFill>
-            <a:srgbClr val="2F4858"/>
+            <a:srgbClr val="E2EAEF"/>
           </a:solidFill>
           <a:ln>
             <a:noFill/>
@@ -5541,7 +5839,7 @@
             <a:r>
               <a:rPr sz="1500" b="0">
                 <a:solidFill>
-                  <a:srgbClr val="FFFFFF"/>
+                  <a:srgbClr val="2F4858"/>
                 </a:solidFill>
                 <a:latin typeface="微软雅黑"/>
                 <a:ea typeface="微软雅黑"/>
@@ -5648,7 +5946,7 @@
             </a:avLst>
           </a:prstGeom>
           <a:solidFill>
-            <a:srgbClr val="2F4858"/>
+            <a:srgbClr val="E2EAEF"/>
           </a:solidFill>
           <a:ln>
             <a:noFill/>
@@ -5703,7 +6001,7 @@
             <a:r>
               <a:rPr sz="1500" b="0">
                 <a:solidFill>
-                  <a:srgbClr val="FFFFFF"/>
+                  <a:srgbClr val="2F4858"/>
                 </a:solidFill>
                 <a:latin typeface="微软雅黑"/>
                 <a:ea typeface="微软雅黑"/>
@@ -5870,7 +6168,7 @@
                 <a:latin typeface="微软雅黑"/>
                 <a:ea typeface="微软雅黑"/>
               </a:rPr>
-              <a:t>我不想念课本——我想用一段自己的经历，和它们一一对上。</a:t>
+              <a:t>不是上课——就是借这三句话，讲讲我自己的故事。</a:t>
             </a:r>
           </a:p>
         </p:txBody>

</xml_diff>

<commit_message>
Site updated: 2026-10-13 20:35:27
</commit_message>
<xml_diff>
--- a/files/creating-a-meaningful-life.pptx
+++ b/files/creating-a-meaningful-life.pptx
@@ -3144,22 +3144,20 @@
       </p:sp>
       <p:sp>
         <p:nvSpPr>
-          <p:cNvPr id="3" name="Rounded Rectangle 2"/>
+          <p:cNvPr id="3" name="Rectangle 2"/>
           <p:cNvSpPr/>
           <p:nvPr/>
         </p:nvSpPr>
         <p:spPr>
           <a:xfrm>
-            <a:off x="7452360" y="1188720"/>
-            <a:ext cx="3867912" cy="4526280"/>
-          </a:xfrm>
-          <a:prstGeom prst="roundRect">
-            <a:avLst>
-              <a:gd name="adj" fmla="val 5000"/>
-            </a:avLst>
-          </a:prstGeom>
-          <a:solidFill>
-            <a:srgbClr val="EEF2F5"/>
+            <a:off x="2743200" y="1097280"/>
+            <a:ext cx="6702552" cy="9144"/>
+          </a:xfrm>
+          <a:prstGeom prst="rect">
+            <a:avLst/>
+          </a:prstGeom>
+          <a:solidFill>
+            <a:srgbClr val="DDE3E8"/>
           </a:solidFill>
           <a:ln>
             <a:noFill/>
@@ -3190,14 +3188,86 @@
       </p:sp>
       <p:sp>
         <p:nvSpPr>
-          <p:cNvPr id="4" name="Rectangle 3"/>
+          <p:cNvPr id="4" name="TextBox 3"/>
+          <p:cNvSpPr txBox="1"/>
+          <p:nvPr/>
+        </p:nvSpPr>
+        <p:spPr>
+          <a:xfrm>
+            <a:off x="822960" y="1243584"/>
+            <a:ext cx="10543032" cy="365760"/>
+          </a:xfrm>
+          <a:prstGeom prst="rect">
+            <a:avLst/>
+          </a:prstGeom>
+          <a:noFill/>
+        </p:spPr>
+        <p:txBody>
+          <a:bodyPr wrap="square" anchor="t">
+            <a:spAutoFit/>
+          </a:bodyPr>
+          <a:lstStyle/>
+          <a:p>
+            <a:pPr algn="ctr"/>
+            <a:r>
+              <a:rPr sz="1250" b="0">
+                <a:solidFill>
+                  <a:srgbClr val="5F6B76"/>
+                </a:solidFill>
+                <a:latin typeface="微软雅黑"/>
+                <a:ea typeface="微软雅黑"/>
+              </a:rPr>
+              <a:t>思想道德与法治 · 课前分享</a:t>
+            </a:r>
+          </a:p>
+        </p:txBody>
+      </p:sp>
+      <p:sp>
+        <p:nvSpPr>
+          <p:cNvPr id="5" name="TextBox 4"/>
+          <p:cNvSpPr txBox="1"/>
+          <p:nvPr/>
+        </p:nvSpPr>
+        <p:spPr>
+          <a:xfrm>
+            <a:off x="822960" y="2560320"/>
+            <a:ext cx="10543032" cy="960120"/>
+          </a:xfrm>
+          <a:prstGeom prst="rect">
+            <a:avLst/>
+          </a:prstGeom>
+          <a:noFill/>
+        </p:spPr>
+        <p:txBody>
+          <a:bodyPr wrap="square" anchor="t">
+            <a:spAutoFit/>
+          </a:bodyPr>
+          <a:lstStyle/>
+          <a:p>
+            <a:pPr algn="ctr"/>
+            <a:r>
+              <a:rPr sz="4200" b="0">
+                <a:solidFill>
+                  <a:srgbClr val="1B1B1B"/>
+                </a:solidFill>
+                <a:latin typeface="微软雅黑 Light"/>
+                <a:ea typeface="微软雅黑 Light"/>
+              </a:rPr>
+              <a:t>创造有意义的人生</a:t>
+            </a:r>
+          </a:p>
+        </p:txBody>
+      </p:sp>
+      <p:sp>
+        <p:nvSpPr>
+          <p:cNvPr id="6" name="Rectangle 5"/>
           <p:cNvSpPr/>
           <p:nvPr/>
         </p:nvSpPr>
         <p:spPr>
           <a:xfrm>
-            <a:off x="7452360" y="1188720"/>
-            <a:ext cx="64008" cy="4526280"/>
+            <a:off x="5550408" y="3749039"/>
+            <a:ext cx="1097280" cy="45720"/>
           </a:xfrm>
           <a:prstGeom prst="rect">
             <a:avLst/>
@@ -3234,20 +3304,56 @@
       </p:sp>
       <p:sp>
         <p:nvSpPr>
-          <p:cNvPr id="5" name="Rectangle 4"/>
+          <p:cNvPr id="7" name="TextBox 6"/>
+          <p:cNvSpPr txBox="1"/>
+          <p:nvPr/>
+        </p:nvSpPr>
+        <p:spPr>
+          <a:xfrm>
+            <a:off x="822960" y="3931920"/>
+            <a:ext cx="10543032" cy="548640"/>
+          </a:xfrm>
+          <a:prstGeom prst="rect">
+            <a:avLst/>
+          </a:prstGeom>
+          <a:noFill/>
+        </p:spPr>
+        <p:txBody>
+          <a:bodyPr wrap="square" anchor="t">
+            <a:spAutoFit/>
+          </a:bodyPr>
+          <a:lstStyle/>
+          <a:p>
+            <a:pPr algn="ctr"/>
+            <a:r>
+              <a:rPr sz="2000" b="0">
+                <a:solidFill>
+                  <a:srgbClr val="2F4858"/>
+                </a:solidFill>
+                <a:latin typeface="微软雅黑 Light"/>
+                <a:ea typeface="微软雅黑 Light"/>
+              </a:rPr>
+              <a:t>从一次被否定说起</a:t>
+            </a:r>
+          </a:p>
+        </p:txBody>
+      </p:sp>
+      <p:sp>
+        <p:nvSpPr>
+          <p:cNvPr id="8" name="Rectangle 7"/>
           <p:cNvSpPr/>
           <p:nvPr/>
         </p:nvSpPr>
         <p:spPr>
           <a:xfrm>
-            <a:off x="7818120" y="1536192"/>
-            <a:ext cx="118872" cy="118872"/>
-          </a:xfrm>
-          <a:prstGeom prst="rect">
-            <a:avLst/>
-          </a:prstGeom>
-          <a:solidFill>
-            <a:srgbClr val="52798A"/>
+            <a:off x="2743200" y="4937760"/>
+            <a:ext cx="6702552" cy="9144"/>
+          </a:xfrm>
+          <a:prstGeom prst="rect">
+            <a:avLst/>
+          </a:prstGeom>
+          <a:solidFill>
+            <a:srgbClr val="DDE3E8"/>
           </a:solidFill>
           <a:ln>
             <a:noFill/>
@@ -3278,14 +3384,14 @@
       </p:sp>
       <p:sp>
         <p:nvSpPr>
-          <p:cNvPr id="6" name="TextBox 5"/>
+          <p:cNvPr id="9" name="TextBox 8"/>
           <p:cNvSpPr txBox="1"/>
           <p:nvPr/>
         </p:nvSpPr>
         <p:spPr>
           <a:xfrm>
-            <a:off x="8037575" y="1481328"/>
-            <a:ext cx="3017520" cy="320040"/>
+            <a:off x="822960" y="5074920"/>
+            <a:ext cx="10543032" cy="914400"/>
           </a:xfrm>
           <a:prstGeom prst="rect">
             <a:avLst/>
@@ -3298,557 +3404,7 @@
           </a:bodyPr>
           <a:lstStyle/>
           <a:p>
-            <a:pPr algn="l"/>
-            <a:r>
-              <a:rPr sz="1200" b="0">
-                <a:solidFill>
-                  <a:srgbClr val="2F4858"/>
-                </a:solidFill>
-                <a:latin typeface="微软雅黑"/>
-                <a:ea typeface="微软雅黑"/>
-              </a:rPr>
-              <a:t>本次分享</a:t>
-            </a:r>
-          </a:p>
-        </p:txBody>
-      </p:sp>
-      <p:sp>
-        <p:nvSpPr>
-          <p:cNvPr id="7" name="Rectangle 6"/>
-          <p:cNvSpPr/>
-          <p:nvPr/>
-        </p:nvSpPr>
-        <p:spPr>
-          <a:xfrm>
-            <a:off x="7818120" y="1993392"/>
-            <a:ext cx="3108960" cy="12801"/>
-          </a:xfrm>
-          <a:prstGeom prst="rect">
-            <a:avLst/>
-          </a:prstGeom>
-          <a:solidFill>
-            <a:srgbClr val="8FA6B4"/>
-          </a:solidFill>
-          <a:ln>
-            <a:noFill/>
-          </a:ln>
-          <a:effectLst/>
-        </p:spPr>
-        <p:style>
-          <a:lnRef idx="1">
-            <a:schemeClr val="accent1"/>
-          </a:lnRef>
-          <a:fillRef idx="3">
-            <a:schemeClr val="accent1"/>
-          </a:fillRef>
-          <a:effectRef idx="2">
-            <a:schemeClr val="accent1"/>
-          </a:effectRef>
-          <a:fontRef idx="minor">
-            <a:schemeClr val="lt1"/>
-          </a:fontRef>
-        </p:style>
-        <p:txBody>
-          <a:bodyPr rtlCol="0" anchor="ctr"/>
-          <a:lstStyle/>
-          <a:p>
-            <a:pPr algn="ctr"/>
-          </a:p>
-        </p:txBody>
-      </p:sp>
-      <p:sp>
-        <p:nvSpPr>
-          <p:cNvPr id="8" name="Rounded Rectangle 7"/>
-          <p:cNvSpPr/>
-          <p:nvPr/>
-        </p:nvSpPr>
-        <p:spPr>
-          <a:xfrm>
-            <a:off x="7818120" y="2286000"/>
-            <a:ext cx="3108960" cy="658368"/>
-          </a:xfrm>
-          <a:prstGeom prst="roundRect">
-            <a:avLst>
-              <a:gd name="adj" fmla="val 14000"/>
-            </a:avLst>
-          </a:prstGeom>
-          <a:solidFill>
-            <a:srgbClr val="E2EAEF"/>
-          </a:solidFill>
-          <a:ln>
-            <a:noFill/>
-          </a:ln>
-          <a:effectLst/>
-        </p:spPr>
-        <p:style>
-          <a:lnRef idx="1">
-            <a:schemeClr val="accent1"/>
-          </a:lnRef>
-          <a:fillRef idx="3">
-            <a:schemeClr val="accent1"/>
-          </a:fillRef>
-          <a:effectRef idx="2">
-            <a:schemeClr val="accent1"/>
-          </a:effectRef>
-          <a:fontRef idx="minor">
-            <a:schemeClr val="lt1"/>
-          </a:fontRef>
-        </p:style>
-        <p:txBody>
-          <a:bodyPr rtlCol="0" anchor="ctr"/>
-          <a:lstStyle/>
-          <a:p>
-            <a:pPr algn="ctr"/>
-          </a:p>
-        </p:txBody>
-      </p:sp>
-      <p:sp>
-        <p:nvSpPr>
-          <p:cNvPr id="9" name="TextBox 8"/>
-          <p:cNvSpPr txBox="1"/>
-          <p:nvPr/>
-        </p:nvSpPr>
-        <p:spPr>
-          <a:xfrm>
-            <a:off x="7818120" y="2286000"/>
-            <a:ext cx="3108960" cy="658368"/>
-          </a:xfrm>
-          <a:prstGeom prst="rect">
-            <a:avLst/>
-          </a:prstGeom>
-          <a:noFill/>
-        </p:spPr>
-        <p:txBody>
-          <a:bodyPr wrap="square" anchor="ctr">
-            <a:spAutoFit/>
-          </a:bodyPr>
-          <a:lstStyle/>
-          <a:p>
-            <a:pPr algn="ctr"/>
-            <a:r>
-              <a:rPr sz="1700" b="0">
-                <a:solidFill>
-                  <a:srgbClr val="2F4858"/>
-                </a:solidFill>
-                <a:latin typeface="微软雅黑"/>
-                <a:ea typeface="微软雅黑"/>
-              </a:rPr>
-              <a:t>动画</a:t>
-            </a:r>
-          </a:p>
-        </p:txBody>
-      </p:sp>
-      <p:sp>
-        <p:nvSpPr>
-          <p:cNvPr id="10" name="Rounded Rectangle 9"/>
-          <p:cNvSpPr/>
-          <p:nvPr/>
-        </p:nvSpPr>
-        <p:spPr>
-          <a:xfrm>
-            <a:off x="7818120" y="3090672"/>
-            <a:ext cx="3108960" cy="658368"/>
-          </a:xfrm>
-          <a:prstGeom prst="roundRect">
-            <a:avLst>
-              <a:gd name="adj" fmla="val 14000"/>
-            </a:avLst>
-          </a:prstGeom>
-          <a:solidFill>
-            <a:srgbClr val="E2EAEF"/>
-          </a:solidFill>
-          <a:ln>
-            <a:noFill/>
-          </a:ln>
-          <a:effectLst/>
-        </p:spPr>
-        <p:style>
-          <a:lnRef idx="1">
-            <a:schemeClr val="accent1"/>
-          </a:lnRef>
-          <a:fillRef idx="3">
-            <a:schemeClr val="accent1"/>
-          </a:fillRef>
-          <a:effectRef idx="2">
-            <a:schemeClr val="accent1"/>
-          </a:effectRef>
-          <a:fontRef idx="minor">
-            <a:schemeClr val="lt1"/>
-          </a:fontRef>
-        </p:style>
-        <p:txBody>
-          <a:bodyPr rtlCol="0" anchor="ctr"/>
-          <a:lstStyle/>
-          <a:p>
-            <a:pPr algn="ctr"/>
-          </a:p>
-        </p:txBody>
-      </p:sp>
-      <p:sp>
-        <p:nvSpPr>
-          <p:cNvPr id="11" name="TextBox 10"/>
-          <p:cNvSpPr txBox="1"/>
-          <p:nvPr/>
-        </p:nvSpPr>
-        <p:spPr>
-          <a:xfrm>
-            <a:off x="7818120" y="3090672"/>
-            <a:ext cx="3108960" cy="658368"/>
-          </a:xfrm>
-          <a:prstGeom prst="rect">
-            <a:avLst/>
-          </a:prstGeom>
-          <a:noFill/>
-        </p:spPr>
-        <p:txBody>
-          <a:bodyPr wrap="square" anchor="ctr">
-            <a:spAutoFit/>
-          </a:bodyPr>
-          <a:lstStyle/>
-          <a:p>
-            <a:pPr algn="ctr"/>
-            <a:r>
-              <a:rPr sz="1700" b="0">
-                <a:solidFill>
-                  <a:srgbClr val="2F4858"/>
-                </a:solidFill>
-                <a:latin typeface="微软雅黑"/>
-                <a:ea typeface="微软雅黑"/>
-              </a:rPr>
-              <a:t>哲学</a:t>
-            </a:r>
-          </a:p>
-        </p:txBody>
-      </p:sp>
-      <p:sp>
-        <p:nvSpPr>
-          <p:cNvPr id="12" name="Rounded Rectangle 11"/>
-          <p:cNvSpPr/>
-          <p:nvPr/>
-        </p:nvSpPr>
-        <p:spPr>
-          <a:xfrm>
-            <a:off x="7818120" y="3895344"/>
-            <a:ext cx="3108960" cy="658368"/>
-          </a:xfrm>
-          <a:prstGeom prst="roundRect">
-            <a:avLst>
-              <a:gd name="adj" fmla="val 14000"/>
-            </a:avLst>
-          </a:prstGeom>
-          <a:solidFill>
-            <a:srgbClr val="E2EAEF"/>
-          </a:solidFill>
-          <a:ln>
-            <a:noFill/>
-          </a:ln>
-          <a:effectLst/>
-        </p:spPr>
-        <p:style>
-          <a:lnRef idx="1">
-            <a:schemeClr val="accent1"/>
-          </a:lnRef>
-          <a:fillRef idx="3">
-            <a:schemeClr val="accent1"/>
-          </a:fillRef>
-          <a:effectRef idx="2">
-            <a:schemeClr val="accent1"/>
-          </a:effectRef>
-          <a:fontRef idx="minor">
-            <a:schemeClr val="lt1"/>
-          </a:fontRef>
-        </p:style>
-        <p:txBody>
-          <a:bodyPr rtlCol="0" anchor="ctr"/>
-          <a:lstStyle/>
-          <a:p>
-            <a:pPr algn="ctr"/>
-          </a:p>
-        </p:txBody>
-      </p:sp>
-      <p:sp>
-        <p:nvSpPr>
-          <p:cNvPr id="13" name="TextBox 12"/>
-          <p:cNvSpPr txBox="1"/>
-          <p:nvPr/>
-        </p:nvSpPr>
-        <p:spPr>
-          <a:xfrm>
-            <a:off x="7818120" y="3895344"/>
-            <a:ext cx="3108960" cy="658368"/>
-          </a:xfrm>
-          <a:prstGeom prst="rect">
-            <a:avLst/>
-          </a:prstGeom>
-          <a:noFill/>
-        </p:spPr>
-        <p:txBody>
-          <a:bodyPr wrap="square" anchor="ctr">
-            <a:spAutoFit/>
-          </a:bodyPr>
-          <a:lstStyle/>
-          <a:p>
-            <a:pPr algn="ctr"/>
-            <a:r>
-              <a:rPr sz="1700" b="0">
-                <a:solidFill>
-                  <a:srgbClr val="2F4858"/>
-                </a:solidFill>
-                <a:latin typeface="微软雅黑"/>
-                <a:ea typeface="微软雅黑"/>
-              </a:rPr>
-              <a:t>编程</a:t>
-            </a:r>
-          </a:p>
-        </p:txBody>
-      </p:sp>
-      <p:sp>
-        <p:nvSpPr>
-          <p:cNvPr id="14" name="TextBox 13"/>
-          <p:cNvSpPr txBox="1"/>
-          <p:nvPr/>
-        </p:nvSpPr>
-        <p:spPr>
-          <a:xfrm>
-            <a:off x="7818120" y="4828032"/>
-            <a:ext cx="3108960" cy="365760"/>
-          </a:xfrm>
-          <a:prstGeom prst="rect">
-            <a:avLst/>
-          </a:prstGeom>
-          <a:noFill/>
-        </p:spPr>
-        <p:txBody>
-          <a:bodyPr wrap="square" anchor="t">
-            <a:spAutoFit/>
-          </a:bodyPr>
-          <a:lstStyle/>
-          <a:p>
-            <a:pPr algn="l"/>
-            <a:r>
-              <a:rPr sz="1150" b="0">
-                <a:solidFill>
-                  <a:srgbClr val="5F6B76"/>
-                </a:solidFill>
-                <a:latin typeface="微软雅黑"/>
-                <a:ea typeface="微软雅黑"/>
-              </a:rPr>
-              <a:t>一次关于「意义」的自言自语</a:t>
-            </a:r>
-          </a:p>
-        </p:txBody>
-      </p:sp>
-      <p:sp>
-        <p:nvSpPr>
-          <p:cNvPr id="15" name="TextBox 14"/>
-          <p:cNvSpPr txBox="1"/>
-          <p:nvPr/>
-        </p:nvSpPr>
-        <p:spPr>
-          <a:xfrm>
-            <a:off x="7818120" y="5321808"/>
-            <a:ext cx="3108960" cy="320040"/>
-          </a:xfrm>
-          <a:prstGeom prst="rect">
-            <a:avLst/>
-          </a:prstGeom>
-          <a:noFill/>
-        </p:spPr>
-        <p:txBody>
-          <a:bodyPr wrap="square" anchor="t">
-            <a:spAutoFit/>
-          </a:bodyPr>
-          <a:lstStyle/>
-          <a:p>
-            <a:pPr algn="l"/>
-            <a:r>
-              <a:rPr sz="1050" b="0">
-                <a:solidFill>
-                  <a:srgbClr val="98A2AB"/>
-                </a:solidFill>
-                <a:latin typeface="微软雅黑"/>
-                <a:ea typeface="微软雅黑"/>
-              </a:rPr>
-              <a:t>第一章 · 第三节</a:t>
-            </a:r>
-          </a:p>
-        </p:txBody>
-      </p:sp>
-      <p:sp>
-        <p:nvSpPr>
-          <p:cNvPr id="16" name="TextBox 15"/>
-          <p:cNvSpPr txBox="1"/>
-          <p:nvPr/>
-        </p:nvSpPr>
-        <p:spPr>
-          <a:xfrm>
-            <a:off x="960120" y="960120"/>
-            <a:ext cx="6035040" cy="320040"/>
-          </a:xfrm>
-          <a:prstGeom prst="rect">
-            <a:avLst/>
-          </a:prstGeom>
-          <a:noFill/>
-        </p:spPr>
-        <p:txBody>
-          <a:bodyPr wrap="square" anchor="t">
-            <a:spAutoFit/>
-          </a:bodyPr>
-          <a:lstStyle/>
-          <a:p>
-            <a:pPr algn="l"/>
-            <a:r>
-              <a:rPr sz="1250" b="0">
-                <a:solidFill>
-                  <a:srgbClr val="5F6B76"/>
-                </a:solidFill>
-                <a:latin typeface="微软雅黑"/>
-                <a:ea typeface="微软雅黑"/>
-              </a:rPr>
-              <a:t>思想道德与法治 · 课前分享</a:t>
-            </a:r>
-          </a:p>
-        </p:txBody>
-      </p:sp>
-      <p:sp>
-        <p:nvSpPr>
-          <p:cNvPr id="17" name="TextBox 16"/>
-          <p:cNvSpPr txBox="1"/>
-          <p:nvPr/>
-        </p:nvSpPr>
-        <p:spPr>
-          <a:xfrm>
-            <a:off x="960120" y="2240280"/>
-            <a:ext cx="6217920" cy="914400"/>
-          </a:xfrm>
-          <a:prstGeom prst="rect">
-            <a:avLst/>
-          </a:prstGeom>
-          <a:noFill/>
-        </p:spPr>
-        <p:txBody>
-          <a:bodyPr wrap="square" anchor="t">
-            <a:spAutoFit/>
-          </a:bodyPr>
-          <a:lstStyle/>
-          <a:p>
-            <a:pPr algn="l"/>
-            <a:r>
-              <a:rPr sz="4000" b="0">
-                <a:solidFill>
-                  <a:srgbClr val="1B1B1B"/>
-                </a:solidFill>
-                <a:latin typeface="微软雅黑 Light"/>
-                <a:ea typeface="微软雅黑 Light"/>
-              </a:rPr>
-              <a:t>创造有意义的人生</a:t>
-            </a:r>
-          </a:p>
-        </p:txBody>
-      </p:sp>
-      <p:sp>
-        <p:nvSpPr>
-          <p:cNvPr id="18" name="Rectangle 17"/>
-          <p:cNvSpPr/>
-          <p:nvPr/>
-        </p:nvSpPr>
-        <p:spPr>
-          <a:xfrm>
-            <a:off x="960120" y="3310128"/>
-            <a:ext cx="1737360" cy="45720"/>
-          </a:xfrm>
-          <a:prstGeom prst="rect">
-            <a:avLst/>
-          </a:prstGeom>
-          <a:solidFill>
-            <a:srgbClr val="52798A"/>
-          </a:solidFill>
-          <a:ln>
-            <a:noFill/>
-          </a:ln>
-          <a:effectLst/>
-        </p:spPr>
-        <p:style>
-          <a:lnRef idx="1">
-            <a:schemeClr val="accent1"/>
-          </a:lnRef>
-          <a:fillRef idx="3">
-            <a:schemeClr val="accent1"/>
-          </a:fillRef>
-          <a:effectRef idx="2">
-            <a:schemeClr val="accent1"/>
-          </a:effectRef>
-          <a:fontRef idx="minor">
-            <a:schemeClr val="lt1"/>
-          </a:fontRef>
-        </p:style>
-        <p:txBody>
-          <a:bodyPr rtlCol="0" anchor="ctr"/>
-          <a:lstStyle/>
-          <a:p>
-            <a:pPr algn="ctr"/>
-          </a:p>
-        </p:txBody>
-      </p:sp>
-      <p:sp>
-        <p:nvSpPr>
-          <p:cNvPr id="19" name="TextBox 18"/>
-          <p:cNvSpPr txBox="1"/>
-          <p:nvPr/>
-        </p:nvSpPr>
-        <p:spPr>
-          <a:xfrm>
-            <a:off x="960120" y="3520440"/>
-            <a:ext cx="6035040" cy="457200"/>
-          </a:xfrm>
-          <a:prstGeom prst="rect">
-            <a:avLst/>
-          </a:prstGeom>
-          <a:noFill/>
-        </p:spPr>
-        <p:txBody>
-          <a:bodyPr wrap="square" anchor="t">
-            <a:spAutoFit/>
-          </a:bodyPr>
-          <a:lstStyle/>
-          <a:p>
-            <a:pPr algn="l"/>
-            <a:r>
-              <a:rPr sz="2000" b="0">
-                <a:solidFill>
-                  <a:srgbClr val="2F4858"/>
-                </a:solidFill>
-                <a:latin typeface="微软雅黑 Light"/>
-                <a:ea typeface="微软雅黑 Light"/>
-              </a:rPr>
-              <a:t>从一次被否定说起</a:t>
-            </a:r>
-          </a:p>
-        </p:txBody>
-      </p:sp>
-      <p:sp>
-        <p:nvSpPr>
-          <p:cNvPr id="20" name="TextBox 19"/>
-          <p:cNvSpPr txBox="1"/>
-          <p:nvPr/>
-        </p:nvSpPr>
-        <p:spPr>
-          <a:xfrm>
-            <a:off x="960120" y="4892040"/>
-            <a:ext cx="6035040" cy="914400"/>
-          </a:xfrm>
-          <a:prstGeom prst="rect">
-            <a:avLst/>
-          </a:prstGeom>
-          <a:noFill/>
-        </p:spPr>
-        <p:txBody>
-          <a:bodyPr wrap="square" anchor="t">
-            <a:spAutoFit/>
-          </a:bodyPr>
-          <a:lstStyle/>
-          <a:p>
-            <a:pPr algn="l">
+            <a:pPr algn="ctr">
               <a:spcAft>
                 <a:spcPts val="600"/>
               </a:spcAft>
@@ -3865,7 +3421,7 @@
             </a:r>
           </a:p>
           <a:p>
-            <a:pPr algn="l"/>
+            <a:pPr algn="ctr"/>
             <a:r>
               <a:rPr sz="1250" b="0">
                 <a:solidFill>
@@ -3881,13 +3437,13 @@
       </p:sp>
       <p:sp>
         <p:nvSpPr>
-          <p:cNvPr id="21" name="TextBox 20"/>
+          <p:cNvPr id="10" name="TextBox 9"/>
           <p:cNvSpPr txBox="1"/>
           <p:nvPr/>
         </p:nvSpPr>
         <p:spPr>
           <a:xfrm>
-            <a:off x="960120" y="6400800"/>
+            <a:off x="914400" y="6400800"/>
             <a:ext cx="4572000" cy="320040"/>
           </a:xfrm>
           <a:prstGeom prst="rect">
@@ -3917,7 +3473,7 @@
       </p:sp>
       <p:sp>
         <p:nvSpPr>
-          <p:cNvPr id="22" name="TextBox 21"/>
+          <p:cNvPr id="11" name="TextBox 10"/>
           <p:cNvSpPr txBox="1"/>
           <p:nvPr/>
         </p:nvSpPr>

</xml_diff>